<commit_message>
Add the Kaggle notebook link, and fill the deck's closing slide
- README: Kaggle notebook row, pointing at the public, successfully
  committed notebook (esraamaamoun/real-estate-machine-house-price-valuation).
- Real_Estate_Machine_defense.pptx, slide 20 only: the three links
  (live app, code, Kaggle) replace "to be added once deployed", and the
  QR code for the live app replaces the placeholder frame, with the
  speaker note build_deck.js writes once the QR exists. Every other part
  of the file is byte-for-byte unchanged.
- deck_facts.json: kaggle_url added beside live_url and repo_url, so a
  rebuild with build_deck.js produces the same slide.
- qr_live_app.png: committed, since build_deck.js reads it.

Co-Authored-By: Claude Opus 5.5 <noreply@anthropic.com>
Claude-Session: https://claude.ai/code/session_01UdvyXfiq19JkQRSSs3Tq74
</commit_message>
<xml_diff>
--- a/reports/Real_Estate_Machine_defense.pptx
+++ b/reports/Real_Estate_Machine_defense.pptx
@@ -1593,11 +1593,8 @@
           <a:lstStyle/>
           <a:p>
             <a:r>
-              <a:rPr lang="en-US" dirty="0"/>
-              <a:t>The three links and the QR are empty because nothing is deployed yet. Once it is: run `python scripts/make_qr.py &lt;your streamlit url&gt;`, then `node scripts/build_deck.js`, and this slide fills itself in - the QR, the link text and the colours are already laid out for it.
-If you present before deploying, say 'it runs locally and I have just shown you' and move on; do not apologise for the empty slots.</a:t>
-            </a:r>
-            <a:endParaRPr lang="en-US" dirty="0"/>
+              <a:t>The QR points at the live app. Leave this slide up during questions - anyone in the room can open the tool on their own phone while you answer.</a:t>
+            </a:r>
           </a:p>
         </p:txBody>
       </p:sp>
@@ -9235,6 +9232,10 @@
             <a:prstDash val="solid"/>
           </a:ln>
         </p:spPr>
+        <p:txBody>
+          <a:bodyPr/>
+          <a:p/>
+        </p:txBody>
       </p:sp>
       <p:sp>
         <p:nvSpPr>
@@ -9260,6 +9261,10 @@
             <a:prstDash val="solid"/>
           </a:ln>
         </p:spPr>
+        <p:txBody>
+          <a:bodyPr/>
+          <a:p/>
+        </p:txBody>
       </p:sp>
       <p:sp>
         <p:nvSpPr>
@@ -9365,6 +9370,10 @@
             <a:prstDash val="solid"/>
           </a:ln>
         </p:spPr>
+        <p:txBody>
+          <a:bodyPr/>
+          <a:p/>
+        </p:txBody>
       </p:sp>
       <p:sp>
         <p:nvSpPr>
@@ -9430,15 +9439,15 @@
               <a:buNone/>
             </a:pPr>
             <a:r>
-              <a:rPr lang="en-US" sz="1300" i="1" dirty="0">
-                <a:solidFill>
-                  <a:srgbClr val="8A8177"/>
-                </a:solidFill>
-                <a:latin typeface="Calibri" pitchFamily="34" charset="0"/>
-                <a:ea typeface="Calibri" pitchFamily="34" charset="-122"/>
-                <a:cs typeface="Calibri" pitchFamily="34" charset="-120"/>
-              </a:rPr>
-              <a:t>to be added once deployed</a:t>
+              <a:rPr lang="en-US" sz="1300" i="0" dirty="0">
+                <a:solidFill>
+                  <a:srgbClr val="FFFFFF"/>
+                </a:solidFill>
+                <a:latin typeface="Calibri" pitchFamily="34" charset="0"/>
+                <a:ea typeface="Calibri" pitchFamily="34" charset="-122"/>
+                <a:cs typeface="Calibri" pitchFamily="34" charset="-120"/>
+              </a:rPr>
+              <a:t>real-estate-machine-esraa.streamlit.app</a:t>
             </a:r>
             <a:endParaRPr lang="en-US" sz="1300" dirty="0"/>
           </a:p>
@@ -9470,6 +9479,10 @@
             <a:prstDash val="solid"/>
           </a:ln>
         </p:spPr>
+        <p:txBody>
+          <a:bodyPr/>
+          <a:p/>
+        </p:txBody>
       </p:sp>
       <p:sp>
         <p:nvSpPr>
@@ -9535,15 +9548,15 @@
               <a:buNone/>
             </a:pPr>
             <a:r>
-              <a:rPr lang="en-US" sz="1300" i="1" dirty="0">
-                <a:solidFill>
-                  <a:srgbClr val="8A8177"/>
-                </a:solidFill>
-                <a:latin typeface="Calibri" pitchFamily="34" charset="0"/>
-                <a:ea typeface="Calibri" pitchFamily="34" charset="-122"/>
-                <a:cs typeface="Calibri" pitchFamily="34" charset="-120"/>
-              </a:rPr>
-              <a:t>to be added once deployed</a:t>
+              <a:rPr lang="en-US" sz="1300" i="0" dirty="0">
+                <a:solidFill>
+                  <a:srgbClr val="FFFFFF"/>
+                </a:solidFill>
+                <a:latin typeface="Calibri" pitchFamily="34" charset="0"/>
+                <a:ea typeface="Calibri" pitchFamily="34" charset="-122"/>
+                <a:cs typeface="Calibri" pitchFamily="34" charset="-120"/>
+              </a:rPr>
+              <a:t>github.com/EsraaMaamoun/real-estate-machine</a:t>
             </a:r>
             <a:endParaRPr lang="en-US" sz="1300" dirty="0"/>
           </a:p>
@@ -9575,6 +9588,10 @@
             <a:prstDash val="solid"/>
           </a:ln>
         </p:spPr>
+        <p:txBody>
+          <a:bodyPr/>
+          <a:p/>
+        </p:txBody>
       </p:sp>
       <p:sp>
         <p:nvSpPr>
@@ -9640,15 +9657,15 @@
               <a:buNone/>
             </a:pPr>
             <a:r>
-              <a:rPr lang="en-US" sz="1300" i="1" dirty="0">
-                <a:solidFill>
-                  <a:srgbClr val="8A8177"/>
-                </a:solidFill>
-                <a:latin typeface="Calibri" pitchFamily="34" charset="0"/>
-                <a:ea typeface="Calibri" pitchFamily="34" charset="-122"/>
-                <a:cs typeface="Calibri" pitchFamily="34" charset="-120"/>
-              </a:rPr>
-              <a:t>to be added once deployed</a:t>
+              <a:rPr lang="en-US" sz="1300" i="0" dirty="0">
+                <a:solidFill>
+                  <a:srgbClr val="FFFFFF"/>
+                </a:solidFill>
+                <a:latin typeface="Calibri" pitchFamily="34" charset="0"/>
+                <a:ea typeface="Calibri" pitchFamily="34" charset="-122"/>
+                <a:cs typeface="Calibri" pitchFamily="34" charset="-120"/>
+              </a:rPr>
+              <a:t>kaggle.com/code/esraamaamoun/real-estate-machine-house-price-valuation</a:t>
             </a:r>
             <a:endParaRPr lang="en-US" sz="1300" dirty="0"/>
           </a:p>
@@ -9671,109 +9688,18 @@
             </a:avLst>
           </a:prstGeom>
           <a:solidFill>
-            <a:srgbClr val="2A2621"/>
+            <a:srgbClr val="FBFAF7"/>
           </a:solidFill>
           <a:ln w="15875">
             <a:solidFill>
-              <a:srgbClr val="C07214"/>
+              <a:srgbClr val="FBFAF7"/>
             </a:solidFill>
-            <a:prstDash val="dash"/>
+            <a:prstDash val="solid"/>
           </a:ln>
         </p:spPr>
-      </p:sp>
-      <p:sp>
-        <p:nvSpPr>
-          <p:cNvPr id="16" name="Text 14"/>
-          <p:cNvSpPr/>
-          <p:nvPr/>
-        </p:nvSpPr>
-        <p:spPr>
-          <a:xfrm>
-            <a:off x="7927848" y="3493008"/>
-            <a:ext cx="2697480" cy="457200"/>
-          </a:xfrm>
-          <a:prstGeom prst="rect">
-            <a:avLst/>
-          </a:prstGeom>
-          <a:noFill/>
-          <a:ln/>
-        </p:spPr>
-        <p:txBody>
-          <a:bodyPr wrap="square" lIns="0" tIns="0" rIns="0" bIns="0" rtlCol="0" anchor="ctr"/>
-          <a:lstStyle/>
-          <a:p>
-            <a:pPr algn="ctr" indent="0" marL="0">
-              <a:buNone/>
-            </a:pPr>
-            <a:r>
-              <a:rPr lang="en-US" sz="2600" b="1" dirty="0">
-                <a:solidFill>
-                  <a:srgbClr val="E8B361"/>
-                </a:solidFill>
-                <a:latin typeface="Cambria" pitchFamily="34" charset="0"/>
-                <a:ea typeface="Cambria" pitchFamily="34" charset="-122"/>
-                <a:cs typeface="Cambria" pitchFamily="34" charset="-120"/>
-              </a:rPr>
-              <a:t>QR</a:t>
-            </a:r>
-            <a:endParaRPr lang="en-US" sz="2600" dirty="0"/>
-          </a:p>
-        </p:txBody>
-      </p:sp>
-      <p:sp>
-        <p:nvSpPr>
-          <p:cNvPr id="17" name="Text 15"/>
-          <p:cNvSpPr/>
-          <p:nvPr/>
-        </p:nvSpPr>
-        <p:spPr>
-          <a:xfrm>
-            <a:off x="8110728" y="4005072"/>
-            <a:ext cx="2331720" cy="731520"/>
-          </a:xfrm>
-          <a:prstGeom prst="rect">
-            <a:avLst/>
-          </a:prstGeom>
-          <a:noFill/>
-          <a:ln/>
-        </p:spPr>
-        <p:txBody>
-          <a:bodyPr wrap="square" lIns="0" tIns="0" rIns="0" bIns="0" rtlCol="0" anchor="ctr"/>
-          <a:lstStyle/>
-          <a:p>
-            <a:pPr algn="ctr" indent="0" marL="0">
-              <a:buNone/>
-            </a:pPr>
-            <a:r>
-              <a:rPr lang="en-US" sz="1150" dirty="0">
-                <a:solidFill>
-                  <a:srgbClr val="8A8177"/>
-                </a:solidFill>
-                <a:latin typeface="Calibri" pitchFamily="34" charset="0"/>
-                <a:ea typeface="Calibri" pitchFamily="34" charset="-122"/>
-                <a:cs typeface="Calibri" pitchFamily="34" charset="-120"/>
-              </a:rPr>
-              <a:t>run  scripts/make_qr.py &lt;url&gt;</a:t>
-            </a:r>
-            <a:endParaRPr lang="en-US" sz="1150" dirty="0"/>
-          </a:p>
-          <a:p>
-            <a:pPr algn="ctr" indent="0" marL="0">
-              <a:buNone/>
-            </a:pPr>
-            <a:r>
-              <a:rPr lang="en-US" sz="1150" dirty="0">
-                <a:solidFill>
-                  <a:srgbClr val="8A8177"/>
-                </a:solidFill>
-                <a:latin typeface="Calibri" pitchFamily="34" charset="0"/>
-                <a:ea typeface="Calibri" pitchFamily="34" charset="-122"/>
-                <a:cs typeface="Calibri" pitchFamily="34" charset="-120"/>
-              </a:rPr>
-              <a:t>and rebuild — the code lands here</a:t>
-            </a:r>
-            <a:endParaRPr lang="en-US" sz="1150" dirty="0"/>
-          </a:p>
+        <p:txBody>
+          <a:bodyPr/>
+          <a:p/>
         </p:txBody>
       </p:sp>
       <p:sp>
@@ -9812,6 +9738,65 @@
               <a:t>10.5% median error  ·  a range that widens where the model is weak  ·  a written reason for every number</a:t>
             </a:r>
             <a:endParaRPr lang="en-US" sz="1350" dirty="0"/>
+          </a:p>
+        </p:txBody>
+      </p:sp>
+      <p:pic>
+        <p:nvPicPr>
+          <p:cNvPr id="19" name="Picture 18" descr="qr_live_app.png"/>
+          <p:cNvPicPr>
+            <a:picLocks noChangeAspect="1"/>
+          </p:cNvPicPr>
+          <p:nvPr/>
+        </p:nvPicPr>
+        <p:blipFill>
+          <a:blip r:embed="rId3"/>
+          <a:stretch>
+            <a:fillRect/>
+          </a:stretch>
+        </p:blipFill>
+        <p:spPr>
+          <a:xfrm>
+            <a:off x="8129016" y="2944368"/>
+            <a:ext cx="2295144" cy="2295144"/>
+          </a:xfrm>
+          <a:prstGeom prst="rect">
+            <a:avLst/>
+          </a:prstGeom>
+        </p:spPr>
+      </p:pic>
+      <p:sp>
+        <p:nvSpPr>
+          <p:cNvPr id="20" name="TextBox 19"/>
+          <p:cNvSpPr txBox="1"/>
+          <p:nvPr/>
+        </p:nvSpPr>
+        <p:spPr>
+          <a:xfrm>
+            <a:off x="7927848" y="5550408"/>
+            <a:ext cx="2697480" cy="274320"/>
+          </a:xfrm>
+          <a:prstGeom prst="rect">
+            <a:avLst/>
+          </a:prstGeom>
+          <a:noFill/>
+        </p:spPr>
+        <p:txBody>
+          <a:bodyPr wrap="none" lIns="0" rIns="0" tIns="0" bIns="0">
+            <a:spAutoFit/>
+          </a:bodyPr>
+          <a:lstStyle/>
+          <a:p>
+            <a:pPr algn="ctr"/>
+            <a:r>
+              <a:rPr sz="1150">
+                <a:solidFill>
+                  <a:srgbClr val="D9D2C6"/>
+                </a:solidFill>
+                <a:latin typeface="Calibri"/>
+              </a:rPr>
+              <a:t>Scan to open the live app</a:t>
+            </a:r>
           </a:p>
         </p:txBody>
       </p:sp>

</xml_diff>

<commit_message>
Defense deck: the same pre-submission fixes, applied to the slides
Mirrors 2748bd8 (build_deck.js + deck_facts.json), edited in place so every
other slide stays byte-for-byte as it was:
- Slide 12: GB vs XGB CI [-0.92, +0.40], Wilcoxon p = 0.12 (notebook 09),
  replacing the refit's [-1.25, +0.15], p = 0.84; speaker note updated.
- Slide 14: Zillow figures 7.0% / 1.8%, checked 24 September 2026, framed as
  context; chart regenerated.
- Slides 9, 10, 13: "valuation benchmark" / "valuation workflow" wording;
  slide 9 chart label regenerated.
- Slides 1, 17, 20 and the file title: The Real Estate Machine - Graduation
  Project; EstateIQ - AI-Assisted Real Estate Valuation & Decision Support.
- Slide 19: "more than a decade stale" instead of "eleven years".

Co-Authored-By: Claude Opus 5.5 <noreply@anthropic.com>
Claude-Session: https://claude.ai/code/session_01UdvyXfiq19JkQRSSs3Tq74
</commit_message>
<xml_diff>
--- a/reports/Real_Estate_Machine_defense.pptx
+++ b/reports/Real_Estate_Machine_defense.pptx
@@ -612,7 +612,7 @@
             <a:r>
               <a:rPr lang="en-US" dirty="0"/>
               <a:t>Slow down here. This is where the examiners find out whether the modelling served a decision.
-One concrete example: a broker with 200 listings runs them all through the app in a minute, quotes a range rather than a number, and sends a valuer only to the 30 the model is least sure about.</a:t>
+One concrete example: a team with 200 listings runs them all through the app in a minute, quotes a range rather than a number, and sends a valuer only to the 30 the model is least sure about.</a:t>
             </a:r>
             <a:endParaRPr lang="en-US" dirty="0"/>
           </a:p>
@@ -790,7 +790,7 @@
             <a:r>
               <a:rPr lang="en-US" dirty="0"/>
               <a:t>This is the slide that separates the project from a leaderboard exercise, and the honesty is the point. Do not say 'slightly better'; say 'not distinguishable'.
-One technical footnote in case it is asked: the paired test needs both models' predictions, so XGBoost was refitted with the parameters your grid search chose. That refit scores 10.95% against the 10.78% in notebook 09 — a 0.17-point difference between two fits of the same configuration, which is an order of magnitude smaller than the confidence interval on the comparison. The point estimate quoted here is from the notebook table so that it matches the previous slide.
+Every number on this slide comes from notebook 09, section 8 — the same run that produced the comparison table on the previous slide, so the two slides cannot disagree. One more detail if asked: gradient boosting has the smaller error on only 47% of individual houses, which is one more sign of a tie, not a hidden loss.
 Both comparisons are paired — the same 869 houses, both models — with a Wilcoxon signed-rank test and a 2,000-sample bootstrap on the difference in median error.
 If an examiner opens model_comparison.csv and finds XGBoost ahead on R², you have already said it. That is the whole reason it is on the slide.</a:t>
             </a:r>
@@ -880,7 +880,7 @@
           <a:p>
             <a:r>
               <a:rPr lang="en-US" dirty="0"/>
-              <a:t>IAAO = International Association of Assessing Officers; this is their Standard on Ratio Studies. Name the source out loud — it shows the criterion came from the industry, not from me.
+              <a:t>IAAO = International Association of Assessing Officers; this is their Standard on Ratio Studies. Name the source out loud — it shows the criterion is a published valuation benchmark, not one I invented.
 Be honest that COD 14.6 and PRD 1.030 sit near the edges of their bands, not comfortably inside. The next slide but one explains why PRD is strained: the top decile.
 If pressed on the final choice: gradient boosting is in scikit-learn, so deployment needs no extra package; XGBoost would add one for a difference the test set cannot detect. That is an engineering reason, and I would rather give an engineering reason than pretend the data chose.</a:t>
             </a:r>
@@ -972,7 +972,7 @@
               <a:rPr lang="en-US" dirty="0"/>
               <a:t>'Is 10-15% error good enough for a real business?' — quote both the median (10.5%) and the mean (14.6%); the mean is dragged by the tail and hiding that would be dishonest.
 The answer: not for a mortgage valuation, where a lender needs an appraisal. Yes for screening, portfolio triage, and giving a seller a starting range in seconds.
-Source for the Zillow figures: zillow.com/z/zestimate, their own published accuracy page.</a:t>
+Source for the Zillow figures: https://www.zillow.com/how-much-is-my-home-worth/ — Zillow's own published nationwide median error rates (1.83% on-market, 7.01% off-market), checked 24 September 2026. Zillow updates these figures, so quote the date you checked them. They describe the whole US market today, not King County in 2014: context for the number, not a like-for-like test.</a:t>
             </a:r>
             <a:endParaRPr lang="en-US" dirty="0"/>
           </a:p>
@@ -2215,7 +2215,7 @@
           <a:p>
             <a:r>
               <a:rPr lang="en-US" dirty="0"/>
-              <a:t>The sentence to say: 'On a portfolio of 200 properties, the difference between this model and the rule of thumb a broker uses today is about $3.7m of valuation error — and it takes a minute to run.'
+              <a:t>The sentence to say: 'On a portfolio of 200 properties, the difference between this model and a zip-code price-per-sqft valuation benchmark is about $3.7m of valuation error — and it takes a minute to run.'
 Be careful with that framing under questioning: it is error, not profit. The value is in better decisions — which properties to visit, which to bid on, what range to quote — not in the arithmetic itself.
 Cost: the app runs on a free tier. Time: about a second per valuation.</a:t>
             </a:r>
@@ -3074,7 +3074,7 @@
         <p:spPr>
           <a:xfrm>
             <a:off x="749808" y="6236208"/>
-            <a:ext cx="5486400" cy="320040"/>
+            <a:ext cx="10058400" cy="320040"/>
           </a:xfrm>
           <a:prstGeom prst="rect">
             <a:avLst/>
@@ -3098,7 +3098,7 @@
                 <a:ea typeface="Calibri" pitchFamily="34" charset="-122"/>
                 <a:cs typeface="Calibri" pitchFamily="34" charset="-120"/>
               </a:rPr>
-              <a:t>Esraa Maamoun</a:t>
+              <a:t>Esraa Maamoun   ·   App: EstateIQ — AI-Assisted Real Estate Valuation &amp; Decision Support</a:t>
             </a:r>
             <a:endParaRPr lang="en-US" sz="1300" dirty="0"/>
           </a:p>
@@ -3208,7 +3208,7 @@
                 <a:ea typeface="Cambria" pitchFamily="34" charset="-122"/>
                 <a:cs typeface="Cambria" pitchFamily="34" charset="-120"/>
               </a:rPr>
-              <a:t>What a broker should actually do on Monday</a:t>
+              <a:t>What a valuation workflow should do on Monday</a:t>
             </a:r>
             <a:endParaRPr lang="en-US" sz="3000" dirty="0"/>
           </a:p>
@@ -4491,7 +4491,7 @@
                 <a:ea typeface="Calibri" pitchFamily="34" charset="-122"/>
                 <a:cs typeface="Calibri" pitchFamily="34" charset="-120"/>
               </a:rPr>
-              <a:t>95% bootstrap CI [-1.25, +0.15]</a:t>
+              <a:t>95% bootstrap CI [-0.92, +0.40]</a:t>
             </a:r>
             <a:endParaRPr lang="en-US" sz="1350" dirty="0"/>
           </a:p>
@@ -4508,7 +4508,7 @@
                 <a:ea typeface="Calibri" pitchFamily="34" charset="-122"/>
                 <a:cs typeface="Calibri" pitchFamily="34" charset="-120"/>
               </a:rPr>
-              <a:t>p = 0.84   →   not distinguishable</a:t>
+              <a:t>Wilcoxon p = 0.12   →   not distinguishable</a:t>
             </a:r>
             <a:endParaRPr lang="en-US" sz="1350" dirty="0"/>
           </a:p>
@@ -5223,7 +5223,7 @@
                 <a:ea typeface="Calibri" pitchFamily="34" charset="-122"/>
                 <a:cs typeface="Calibri" pitchFamily="34" charset="-120"/>
               </a:rPr>
-              <a:t>The fair comparison is the off-market one.</a:t>
+              <a:t>The fairer reference point is the off-market one.</a:t>
             </a:r>
             <a:endParaRPr lang="en-US" sz="1600" dirty="0"/>
           </a:p>
@@ -5262,7 +5262,7 @@
                 <a:ea typeface="Calibri" pitchFamily="34" charset="-122"/>
                 <a:cs typeface="Calibri" pitchFamily="34" charset="-120"/>
               </a:rPr>
-              <a:t>Zillow's on-market Zestimate is four times more accurate than its off-market one — because for a listed home the model can see the asking price. Mine cannot; it sees 20 columns and ten weeks of 2014. Against the off-market figure, on a student dataset, 10.5% is roughly half the distance to a commercial product. 48% of valuations land within 10% of the sale price.</a:t>
+              <a:t>Zillow's own published figures: 7.0% median error off-market, 1.8% on-market, where the model can see the asking price (zillow.com, checked 24 September 2026). Mine has no asking price; it sees 20 columns and ten weeks of 2014 in one county. Different market, years and data: context, not a head-to-head. 48% of my valuations land within 10% of the sale price.</a:t>
             </a:r>
             <a:endParaRPr lang="en-US" sz="1350" dirty="0"/>
           </a:p>
@@ -5784,7 +5784,7 @@
                 <a:ea typeface="Cambria" pitchFamily="34" charset="-122"/>
                 <a:cs typeface="Cambria" pitchFamily="34" charset="-120"/>
               </a:rPr>
-              <a:t>The product: a number, a range, a reason, a warning</a:t>
+              <a:t>EstateIQ: a number, a range, a reason, a warning</a:t>
             </a:r>
             <a:endParaRPr lang="en-US" sz="3000" dirty="0"/>
           </a:p>
@@ -7914,7 +7914,7 @@
                 <a:ea typeface="Calibri" pitchFamily="34" charset="-122"/>
                 <a:cs typeface="Calibri" pitchFamily="34" charset="-120"/>
               </a:rPr>
-              <a:t>No seasonality, no trend, a price level eleven years stale.</a:t>
+              <a:t>No seasonality, no trend, a price level more than a decade stale.</a:t>
             </a:r>
             <a:endParaRPr lang="en-US" sz="1250" dirty="0"/>
           </a:p>
@@ -9408,7 +9408,7 @@
                 <a:ea typeface="Calibri" pitchFamily="34" charset="-122"/>
                 <a:cs typeface="Calibri" pitchFamily="34" charset="-120"/>
               </a:rPr>
-              <a:t>Live app</a:t>
+              <a:t>EstateIQ live app</a:t>
             </a:r>
             <a:endParaRPr lang="en-US" sz="1250" dirty="0"/>
           </a:p>
@@ -12490,7 +12490,7 @@
                 <a:ea typeface="Calibri" pitchFamily="34" charset="-122"/>
                 <a:cs typeface="Calibri" pitchFamily="34" charset="-120"/>
               </a:rPr>
-              <a:t>Less error per house than the broker's price-per-sqft rule of thumb</a:t>
+              <a:t>Less error per house than a zip price-per-sqft valuation benchmark</a:t>
             </a:r>
             <a:endParaRPr lang="en-US" sz="1250" dirty="0"/>
           </a:p>

</xml_diff>

<commit_message>
Defense deck: presentation-prep edits
- Slide 3: cleaning stated exactly - 256 rows removed (248 zero prices,
  7 impossible prices, 1 duplicate; 5.6% of the file), no price cap
  ($7.06m Bellevue house kept, $26.6m for 1,180 sqft in Kent removed).
- Slide 5: zip code carries 46% of the model's importance, living area 21%.
- Slides 1, 2, 10: "in seconds", "at almost no cost".
- Slide 17: warnings list says "weak or borderline segment".
- Speaker notes: 30-minute talk including the demo, cleaning detail.
Checked against Data/ and Models/regressor.pkl; slide 12 unchanged.
The _links copy of the deck stays local (.gitignore).

Co-Authored-By: Claude Opus 5.5 <noreply@anthropic.com>
Claude-Session: https://claude.ai/code/session_01UdvyXfiq19JkQRSSs3Tq74
</commit_message>
<xml_diff>
--- a/reports/Real_Estate_Machine_defense.pptx
+++ b/reports/Real_Estate_Machine_defense.pptx
@@ -521,9 +521,9 @@
           <a:p>
             <a:r>
               <a:rPr lang="en-US" dirty="0"/>
-              <a:t>Opening line: 'I built a tool that values a house in about a second, tells you how much to trust the number, and writes the reasoning in plain English. I will show you the tool at the end. First, what it is for and why the number is defensible.'
+              <a:t>Opening line: 'I built a tool that values a house in a few seconds, tells you how much to trust the number, and writes the reasoning in plain English. I will show you the tool at the end. First, what it is for and why the number is defensible.'
 The three figures at the foot are the whole argument in advance: accuracy, what that means in money, and the size of the evidence.
-Timing target: 14 minutes, leaving time for questions.</a:t>
+Timing target: 30 minutes including the live demo, then 4 minutes of prepared questions. Follow reports/presentation/Presentation_Script_EN.docx.</a:t>
             </a:r>
             <a:endParaRPr lang="en-US" dirty="0"/>
           </a:p>
@@ -1680,7 +1680,7 @@
           <a:p>
             <a:r>
               <a:rPr lang="en-US" dirty="0"/>
-              <a:t>'Why did you delete 49 rows?' — a price of 0 or a living area of 0 is impossible, not extreme. 1.1% of the data, nothing to impute. Everything else was kept, including the expensive tail.
+              <a:t>'Why did you delete 256 rows?' — 248 had a price of zero (a missing target: you may impute an input, never the answer), 7 had impossible prices for their own zip code (below 0.25x or above 4x its price per sqft, e.g. $26.6m for 1,180 sqft in Kent), and 1 was a duplicate. 4,601 to 4,345, 5.6%. No price cap: the real $7.06m Bellevue house stays.
 If they ask about the JSON: NaN is not valid JSON, so the file had to be repaired before any parser would read it; 'rooms' listed bedrooms and bathrooms in inconsistent order.</a:t>
             </a:r>
             <a:endParaRPr lang="en-US" dirty="0"/>
@@ -2217,7 +2217,7 @@
               <a:rPr lang="en-US" dirty="0"/>
               <a:t>The sentence to say: 'On a portfolio of 200 properties, the difference between this model and a zip-code price-per-sqft valuation benchmark is about $3.7m of valuation error — and it takes a minute to run.'
 Be careful with that framing under questioning: it is error, not profit. The value is in better decisions — which properties to visit, which to bid on, what range to quote — not in the arithmetic itself.
-Cost: the app runs on a free tier. Time: about a second per valuation.</a:t>
+Cost: the app runs on a free tier. Time: a few seconds per valuation.</a:t>
             </a:r>
             <a:endParaRPr lang="en-US" dirty="0"/>
           </a:p>
@@ -2774,7 +2774,7 @@
                 <a:ea typeface="Calibri" pitchFamily="34" charset="-122"/>
                 <a:cs typeface="Calibri" pitchFamily="34" charset="-120"/>
               </a:rPr>
-              <a:t>Values a house in a second, to within 10.5% — and says how much to trust the number</a:t>
+              <a:t>Values a house in seconds, to within 10.5% — and says how much to trust the number</a:t>
             </a:r>
             <a:endParaRPr lang="en-US" sz="1800" dirty="0"/>
           </a:p>
@@ -3372,7 +3372,7 @@
                 <a:ea typeface="Calibri" pitchFamily="34" charset="-122"/>
                 <a:cs typeface="Calibri" pitchFamily="34" charset="-120"/>
               </a:rPr>
-              <a:t>Location moves price 3.2x; every structural feature combined moves it less. Set the buy list at zip level before anyone visits a house.</a:t>
+              <a:t>Location moves price per sqft 3.2x — more than any single feature of the house. Set the buy list at zip level before anyone visits a house.</a:t>
             </a:r>
             <a:endParaRPr lang="en-US" sz="1250" dirty="0"/>
           </a:p>
@@ -3903,7 +3903,7 @@
                 <a:ea typeface="Calibri" pitchFamily="34" charset="-122"/>
                 <a:cs typeface="Calibri" pitchFamily="34" charset="-120"/>
               </a:rPr>
-              <a:t>The commercial case is not accuracy. It is a defensible number, an honest range and a written reason, in a second, for nothing.</a:t>
+              <a:t>The commercial case is not accuracy. It is a defensible number, an honest range and a written reason, in seconds, at almost no cost.</a:t>
             </a:r>
             <a:endParaRPr lang="en-US" sz="1300" dirty="0"/>
           </a:p>
@@ -6123,7 +6123,7 @@
                 <a:ea typeface="Calibri" pitchFamily="34" charset="-122"/>
                 <a:cs typeface="Calibri" pitchFamily="34" charset="-120"/>
               </a:rPr>
-              <a:t>unknown zip, waterfront, top decile, worst segment</a:t>
+              <a:t>unknown zip, waterfront, top decile, weak or borderline segment</a:t>
             </a:r>
             <a:endParaRPr lang="en-US" sz="1250" dirty="0"/>
           </a:p>
@@ -9170,7 +9170,7 @@
                 <a:ea typeface="Calibri" pitchFamily="34" charset="-122"/>
                 <a:cs typeface="Calibri" pitchFamily="34" charset="-120"/>
               </a:rPr>
-              <a:t>The gap this fills: a number, an honest range around it, and a reason — in about a second, at a cost of effectively zero.</a:t>
+              <a:t>The gap this fills: a number, an honest range around it, and a reason — in a few seconds, at almost no cost.</a:t>
             </a:r>
             <a:endParaRPr lang="en-US" sz="1500" dirty="0"/>
           </a:p>
@@ -9446,6 +9446,7 @@
                 <a:latin typeface="Calibri" pitchFamily="34" charset="0"/>
                 <a:ea typeface="Calibri" pitchFamily="34" charset="-122"/>
                 <a:cs typeface="Calibri" pitchFamily="34" charset="-120"/>
+                <a:hlinkClick r:id="rId10"/>
               </a:rPr>
               <a:t>real-estate-machine-esraa.streamlit.app</a:t>
             </a:r>
@@ -9555,6 +9556,7 @@
                 <a:latin typeface="Calibri" pitchFamily="34" charset="0"/>
                 <a:ea typeface="Calibri" pitchFamily="34" charset="-122"/>
                 <a:cs typeface="Calibri" pitchFamily="34" charset="-120"/>
+                <a:hlinkClick r:id="rId11"/>
               </a:rPr>
               <a:t>github.com/EsraaMaamoun/real-estate-machine</a:t>
             </a:r>
@@ -9664,6 +9666,7 @@
                 <a:latin typeface="Calibri" pitchFamily="34" charset="0"/>
                 <a:ea typeface="Calibri" pitchFamily="34" charset="-122"/>
                 <a:cs typeface="Calibri" pitchFamily="34" charset="-120"/>
+                <a:hlinkClick r:id="rId12"/>
               </a:rPr>
               <a:t>kaggle.com/code/esraamaamoun/real-estate-machine-house-price-valuation</a:t>
             </a:r>
@@ -9743,7 +9746,9 @@
       </p:sp>
       <p:pic>
         <p:nvPicPr>
-          <p:cNvPr id="19" name="Picture 18" descr="qr_live_app.png"/>
+          <p:cNvPr id="19" name="Picture 18" descr="qr_live_app.png">
+            <a:hlinkClick r:id="rId10"/>
+          </p:cNvPr>
           <p:cNvPicPr>
             <a:picLocks noChangeAspect="1"/>
           </p:cNvPicPr>
@@ -10282,7 +10287,7 @@
                 <a:ea typeface="Calibri" pitchFamily="34" charset="-122"/>
                 <a:cs typeface="Calibri" pitchFamily="34" charset="-120"/>
               </a:rPr>
-              <a:t>Deleted 49 rows</a:t>
+              <a:t>Deleted 256 rows</a:t>
             </a:r>
             <a:endParaRPr lang="en-US" sz="1500" dirty="0"/>
           </a:p>
@@ -10321,7 +10326,7 @@
                 <a:ea typeface="Calibri" pitchFamily="34" charset="-122"/>
                 <a:cs typeface="Calibri" pitchFamily="34" charset="-120"/>
               </a:rPr>
-              <a:t>Price or living area of zero — missing data wearing a number. 1.1% of the file; imputing a price would invent the target.</a:t>
+              <a:t>248 zero prices, 7 impossible prices and 1 duplicate — 5.6% of the file. Imputing a price would invent the target.</a:t>
             </a:r>
             <a:endParaRPr lang="en-US" sz="1300" dirty="0"/>
           </a:p>
@@ -10387,7 +10392,7 @@
                 <a:ea typeface="Calibri" pitchFamily="34" charset="-122"/>
                 <a:cs typeface="Calibri" pitchFamily="34" charset="-120"/>
               </a:rPr>
-              <a:t>Kept every outlier</a:t>
+              <a:t>Kept the real luxury tail</a:t>
             </a:r>
             <a:endParaRPr lang="en-US" sz="1500" dirty="0"/>
           </a:p>
@@ -10426,7 +10431,7 @@
                 <a:ea typeface="Calibri" pitchFamily="34" charset="-122"/>
                 <a:cs typeface="Calibri" pitchFamily="34" charset="-120"/>
               </a:rPr>
-              <a:t>The $26m sale is real. Dropping hard houses buys a flattering error rate and nothing else.</a:t>
+              <a:t>No price cap: the $7.06m Bellevue house stays. Only prices 4x off their zip's rate went, like $26.6m for 1,180 sqft.</a:t>
             </a:r>
             <a:endParaRPr lang="en-US" sz="1300" dirty="0"/>
           </a:p>
@@ -10636,7 +10641,7 @@
                 <a:ea typeface="Calibri" pitchFamily="34" charset="-122"/>
                 <a:cs typeface="Calibri" pitchFamily="34" charset="-120"/>
               </a:rPr>
-              <a:t>Price divided by size contains the answer. With it, R² is 0.99 and the model can only value houses already sold.</a:t>
+              <a:t>Price divided by size contains the answer. With it, R² is 1.00 and the model can only value houses already sold.</a:t>
             </a:r>
             <a:endParaRPr lang="en-US" sz="1300" dirty="0"/>
           </a:p>
@@ -11087,7 +11092,7 @@
                 <a:ea typeface="Calibri" pitchFamily="34" charset="-122"/>
                 <a:cs typeface="Calibri" pitchFamily="34" charset="-120"/>
               </a:rPr>
-              <a:t>$142 versus $458 per square foot, across the 58 zip codes with 30 or more sales. The encoded zip code alone carries 46% of the model's importance — more than every structural feature combined. Screen the buy list by zip code before anyone visits a property.</a:t>
+              <a:t>$142 versus $458 per square foot, across the 58 zip codes with 30 or more sales. The encoded zip code alone carries 46% of the model's importance — more than twice the next feature, living area (21%). Screen the buy list by zip code before anyone visits a property.</a:t>
             </a:r>
             <a:endParaRPr lang="en-US" sz="1350" dirty="0"/>
           </a:p>
@@ -12644,10 +12649,10 @@
         <a:srgbClr val="70AD47"/>
       </a:accent6>
       <a:hlink>
-        <a:srgbClr val="0563C1"/>
+        <a:srgbClr val="FFFFFF"/>
       </a:hlink>
       <a:folHlink>
-        <a:srgbClr val="954F72"/>
+        <a:srgbClr val="FFFFFF"/>
       </a:folHlink>
     </a:clrScheme>
     <a:fontScheme name="Office">

</xml_diff>